<commit_message>
The English training film and its pictures; two more pictures for the manual
Co-Authored-By: Claude Fable 5.1 <noreply@anthropic.com>
Claude-Session: https://claude.ai/code/session_01LaCZ626Y2oWoWchJeisbmg
</commit_message>
<xml_diff>
--- a/docs/training/scanner-training-en.pptx
+++ b/docs/training/scanner-training-en.pptx
@@ -140,26 +140,26 @@
   <p:extLst>
     <p:ext uri="{521415D9-36F7-43E2-AB2F-B90AF26B5E84}">
       <p14:sectionLst xmlns:p14="http://schemas.microsoft.com/office/powerpoint/2010/main">
-        <p14:section name="Start" id="{e07a84fe-5c25-7018-1ec1-df6461024d0c}">
+        <p14:section name="Start" id="{de717726-24e5-dcda-2718-4ff4a6ac1d5b}">
           <p14:sldIdLst>
             <p14:sldId id="256"/>
           </p14:sldIdLst>
         </p14:section>
-        <p14:section name="Part 1 · Before you start" id="{2b86c78f-71d6-e1fc-b970-5da97aca0595}">
+        <p14:section name="Part 1 · Before you start" id="{26267f4a-d8eb-504c-2f4c-fffbfd76e5e5}">
           <p14:sldIdLst>
             <p14:sldId id="257"/>
             <p14:sldId id="258"/>
             <p14:sldId id="259"/>
           </p14:sldIdLst>
         </p14:section>
-        <p14:section name="Part 2 · Signing on" id="{1f3ed531-4ae1-878c-da68-7163dc466595}">
+        <p14:section name="Part 2 · Signing on" id="{f8ed288c-e766-22e9-f523-6260ff0e56b5}">
           <p14:sldIdLst>
             <p14:sldId id="260"/>
             <p14:sldId id="261"/>
             <p14:sldId id="262"/>
           </p14:sldIdLst>
         </p14:section>
-        <p14:section name="Part 3 · Counting a pallet" id="{90b74fe5-4a47-b134-14ae-512b8b615027}">
+        <p14:section name="Part 3 · Counting a pallet" id="{0677f512-0ed3-4dbe-f120-608486d73bf5}">
           <p14:sldIdLst>
             <p14:sldId id="263"/>
             <p14:sldId id="264"/>
@@ -170,14 +170,14 @@
             <p14:sldId id="269"/>
           </p14:sldIdLst>
         </p14:section>
-        <p14:section name="Part 4 · When a bin is different" id="{3f7f2254-8377-6275-e51f-5a153e746881}">
+        <p14:section name="Part 4 · When a bin is different" id="{56c02401-ddca-a139-86eb-80d993dbe313}">
           <p14:sldIdLst>
             <p14:sldId id="270"/>
             <p14:sldId id="271"/>
             <p14:sldId id="272"/>
           </p14:sldIdLst>
         </p14:section>
-        <p14:section name="Part 5 · Labels" id="{59a24c92-f79b-22a6-16ed-76c3af3240e8}">
+        <p14:section name="Part 5 · Labels" id="{cb68c4e0-982a-c650-2cd9-946c94c244fd}">
           <p14:sldIdLst>
             <p14:sldId id="273"/>
             <p14:sldId id="274"/>
@@ -186,7 +186,7 @@
             <p14:sldId id="277"/>
           </p14:sldIdLst>
         </p14:section>
-        <p14:section name="Part 6 · Help and fixes" id="{92623bd0-dfe2-1b6f-b236-f2628e32e196}">
+        <p14:section name="Part 6 · Help and fixes" id="{89e85bb6-1a3f-e6d6-0107-b2bd25b15a21}">
           <p14:sldIdLst>
             <p14:sldId id="278"/>
             <p14:sldId id="279"/>
@@ -196,14 +196,14 @@
             <p14:sldId id="283"/>
           </p14:sldIdLst>
         </p14:section>
-        <p14:section name="Part 7 · Second counts, and finishing" id="{124885de-4d9b-f1a3-6eec-39426116ba14}">
+        <p14:section name="Part 7 · Second counts, and finishing" id="{fd76aff3-e022-8a54-90fa-8aa6e1cfa80b}">
           <p14:sldIdLst>
             <p14:sldId id="284"/>
             <p14:sldId id="285"/>
             <p14:sldId id="286"/>
           </p14:sldIdLst>
         </p14:section>
-        <p14:section name="The rules" id="{9b8f5ca8-29cb-679a-6c7b-7f6be13541fe}">
+        <p14:section name="The rules" id="{0f4b9baa-04c8-9906-22a2-ddae9186cf14}">
           <p14:sldIdLst>
             <p14:sldId id="287"/>
             <p14:sldId id="288"/>

</xml_diff>

<commit_message>
The training films and decks, in English and Spanish, counting the rack first: under ten minutes each
Co-Authored-By: Claude Fable 5.1 <noreply@anthropic.com>
Claude-Session: https://claude.ai/code/session_01LaCZ626Y2oWoWchJeisbmg
</commit_message>
<xml_diff>
--- a/docs/training/scanner-training-en.pptx
+++ b/docs/training/scanner-training-en.pptx
@@ -140,26 +140,26 @@
   <p:extLst>
     <p:ext uri="{521415D9-36F7-43E2-AB2F-B90AF26B5E84}">
       <p14:sectionLst xmlns:p14="http://schemas.microsoft.com/office/powerpoint/2010/main">
-        <p14:section name="Start" id="{de717726-24e5-dcda-2718-4ff4a6ac1d5b}">
+        <p14:section name="Start" id="{c13ad500-6f40-f93a-37bc-cab53c127dda}">
           <p14:sldIdLst>
             <p14:sldId id="256"/>
           </p14:sldIdLst>
         </p14:section>
-        <p14:section name="Part 1 · Before you start" id="{26267f4a-d8eb-504c-2f4c-fffbfd76e5e5}">
+        <p14:section name="Part 1 · Before you start" id="{86233ead-3660-c4b1-6eff-e9acb494adaf}">
           <p14:sldIdLst>
             <p14:sldId id="257"/>
             <p14:sldId id="258"/>
             <p14:sldId id="259"/>
           </p14:sldIdLst>
         </p14:section>
-        <p14:section name="Part 2 · Signing on" id="{f8ed288c-e766-22e9-f523-6260ff0e56b5}">
+        <p14:section name="Part 2 · Signing on" id="{04b1d7ae-00d9-b809-594b-f1ce3c38f13c}">
           <p14:sldIdLst>
             <p14:sldId id="260"/>
             <p14:sldId id="261"/>
             <p14:sldId id="262"/>
           </p14:sldIdLst>
         </p14:section>
-        <p14:section name="Part 3 · Counting a pallet" id="{0677f512-0ed3-4dbe-f120-608486d73bf5}">
+        <p14:section name="Part 3 · Counting a pallet" id="{ad081d7d-91da-986f-a3b9-cca252e8e416}">
           <p14:sldIdLst>
             <p14:sldId id="263"/>
             <p14:sldId id="264"/>
@@ -170,14 +170,14 @@
             <p14:sldId id="269"/>
           </p14:sldIdLst>
         </p14:section>
-        <p14:section name="Part 4 · When a bin is different" id="{56c02401-ddca-a139-86eb-80d993dbe313}">
+        <p14:section name="Part 4 · When a bin is different" id="{934ad0a2-40e3-c1b5-c7c5-844c3469d697}">
           <p14:sldIdLst>
             <p14:sldId id="270"/>
             <p14:sldId id="271"/>
             <p14:sldId id="272"/>
           </p14:sldIdLst>
         </p14:section>
-        <p14:section name="Part 5 · Labels" id="{cb68c4e0-982a-c650-2cd9-946c94c244fd}">
+        <p14:section name="Part 5 · Labels" id="{166ddce5-7c51-2538-ec00-d888f036924e}">
           <p14:sldIdLst>
             <p14:sldId id="273"/>
             <p14:sldId id="274"/>
@@ -186,7 +186,7 @@
             <p14:sldId id="277"/>
           </p14:sldIdLst>
         </p14:section>
-        <p14:section name="Part 6 · Help and fixes" id="{89e85bb6-1a3f-e6d6-0107-b2bd25b15a21}">
+        <p14:section name="Part 6 · Help and fixes" id="{f19e7d20-7d53-724f-b22a-f28dc6075af5}">
           <p14:sldIdLst>
             <p14:sldId id="278"/>
             <p14:sldId id="279"/>
@@ -196,14 +196,14 @@
             <p14:sldId id="283"/>
           </p14:sldIdLst>
         </p14:section>
-        <p14:section name="Part 7 · Second counts, and finishing" id="{fd76aff3-e022-8a54-90fa-8aa6e1cfa80b}">
+        <p14:section name="Part 7 · Second counts, and finishing" id="{72f11aec-8b30-3509-1c0e-5a0adc611557}">
           <p14:sldIdLst>
             <p14:sldId id="284"/>
             <p14:sldId id="285"/>
             <p14:sldId id="286"/>
           </p14:sldIdLst>
         </p14:section>
-        <p14:section name="The rules" id="{0f4b9baa-04c8-9906-22a2-ddae9186cf14}">
+        <p14:section name="The rules" id="{6e166927-c27c-ad91-2571-461d2a6af3b2}">
           <p14:sldIdLst>
             <p14:sldId id="287"/>
             <p14:sldId id="288"/>
@@ -614,7 +614,7 @@
           <a:p>
             <a:r>
               <a:rPr lang="en-US" dirty="0"/>
-              <a:t>Welcome. Today you learn the scanner. The job is three steps, over and over: scan the pallet label, type how many cases are really there, scan the rack label. Everything else is the scanner helping you when something is unusual. The film shows the same steps slowly; these slides are the same lesson to keep.</a:t>
+              <a:t>Welcome. Today you learn the scanner. The job is three steps, over and over: scan the rack label, scan the pallet label, type how many cases are really there. Everything else is the scanner helping you when something is unusual. The film shows the same steps slowly; these slides are the same lesson to keep.</a:t>
             </a:r>
             <a:endParaRPr lang="en-US" dirty="0"/>
           </a:p>
@@ -702,7 +702,7 @@
           <a:p>
             <a:r>
               <a:rPr lang="en-US" dirty="0"/>
-              <a:t>Show a real pallet label. The barcode is what the scanner reads. The scanner says Pallet F01-001 and nothing about what is on it: that is on purpose.</a:t>
+              <a:t>Show a rack label. It is on the beam under the pallet. Scan the one for the spot you are counting, not the one next to it.</a:t>
             </a:r>
             <a:endParaRPr lang="en-US" dirty="0"/>
           </a:p>
@@ -790,7 +790,7 @@
           <a:p>
             <a:r>
               <a:rPr lang="en-US" dirty="0"/>
-              <a:t>This is the step that matters. If the pallet says 48 and you count 45, type 45. The office works out the rest.</a:t>
+              <a:t>Show a real pallet label. The barcode is what the scanner reads. The scanner says Pallet F01-001 and nothing about what is on it: that is on purpose.</a:t>
             </a:r>
             <a:endParaRPr lang="en-US" dirty="0"/>
           </a:p>
@@ -878,7 +878,7 @@
           <a:p>
             <a:r>
               <a:rPr lang="en-US" dirty="0"/>
-              <a:t>Show a rack label. It is on the beam under the pallet. Scan the one for the spot the pallet is in, not the one next to it.</a:t>
+              <a:t>This is the step that matters. If the pallet says 48 and you count 45, type 45. The office works out the rest.</a:t>
             </a:r>
             <a:endParaRPr lang="en-US" dirty="0"/>
           </a:p>
@@ -1494,7 +1494,7 @@
           <a:p>
             <a:r>
               <a:rPr lang="en-US" dirty="0"/>
-              <a:t>Some pallets carry two loads, each with its own label. Each label gets its own quantity. The rack is scanned once.</a:t>
+              <a:t>Some pallets carry two loads, each with its own label. Each label gets its own quantity. The rack is scanned once, before the button.</a:t>
             </a:r>
             <a:endParaRPr lang="en-US" dirty="0"/>
           </a:p>
@@ -3430,7 +3430,7 @@
           <a:p>
             <a:r>
               <a:rPr lang="en-US" dirty="0"/>
-              <a:t>Three steps, over and over: the pallet, the quantity, the rack.</a:t>
+              <a:t>Three steps, over and over: the rack, the pallet, the quantity.</a:t>
             </a:r>
             <a:endParaRPr lang="en-US" dirty="0"/>
           </a:p>
@@ -4529,7 +4529,7 @@
                   <a:schemeClr val="bg2"/>
                 </a:solidFill>
               </a:rPr>
-              <a:t>Scan the pallet. Type what is there. Scan the rack.</a:t>
+              <a:t>Scan the rack. Scan the pallet. Type what is there.</a:t>
             </a:r>
             <a:endParaRPr lang="en-US" sz="2400" dirty="0"/>
           </a:p>
@@ -4644,7 +4644,7 @@
                   <a:schemeClr val="bg1"/>
                 </a:solidFill>
               </a:rPr>
-              <a:t>1 · Scan the pallet label</a:t>
+              <a:t>1 · Scan the rack label</a:t>
             </a:r>
             <a:endParaRPr lang="en-US" sz="3200" dirty="0"/>
           </a:p>
@@ -4652,7 +4652,7 @@
       </p:sp>
       <p:pic>
         <p:nvPicPr>
-          <p:cNvPr id="4" name="screen pallet-scanned" descr="/home/user/physical-inv-app/docs/training/shots/en/05-pallet-scanned.png">    </p:cNvPr>
+          <p:cNvPr id="4" name="screen rack-scanned" descr="/home/user/physical-inv-app/docs/training/shots/en/05-rack-scanned.png">    </p:cNvPr>
           <p:cNvPicPr>
             <a:picLocks noChangeAspect="1"/>
           </p:cNvPicPr>
@@ -4708,7 +4708,7 @@
                   <a:schemeClr val="bg2"/>
                 </a:solidFill>
               </a:rPr>
-              <a:t>Point the scanner at the barcode on the pallet label. Pull the trigger. Wait for the beep.</a:t>
+              <a:t>Point the scanner at the yellow rack label under the pallet. Pull the trigger. Wait for the beep.</a:t>
             </a:r>
             <a:endParaRPr lang="en-US" sz="2200" dirty="0"/>
           </a:p>
@@ -4726,37 +4726,7 @@
                   <a:schemeClr val="bg2"/>
                 </a:solidFill>
               </a:rPr>
-              <a:t>The scanner shows the pallet number. It does </a:t>
-            </a:r>
-            <a:pPr algn="l" marL="228600" indent="-228600">
-              <a:spcAft>
-                <a:spcPts val="1000"/>
-              </a:spcAft>
-              <a:buSzPct val="100000"/>
-              <a:buChar char="•"/>
-            </a:pPr>
-            <a:r>
-              <a:rPr lang="en-US" sz="2200" b="1" dirty="0">
-                <a:solidFill>
-                  <a:schemeClr val="bg2"/>
-                </a:solidFill>
-              </a:rPr>
-              <a:t>not</a:t>
-            </a:r>
-            <a:pPr algn="l" marL="228600" indent="-228600">
-              <a:spcAft>
-                <a:spcPts val="1000"/>
-              </a:spcAft>
-              <a:buSzPct val="100000"/>
-              <a:buChar char="•"/>
-            </a:pPr>
-            <a:r>
-              <a:rPr lang="en-US" sz="2200" dirty="0">
-                <a:solidFill>
-                  <a:schemeClr val="bg2"/>
-                </a:solidFill>
-              </a:rPr>
-              <a:t> tell you how many should be there.</a:t>
+              <a:t>That tells the system where you are. The scanner checks it is in your aisle and on your levels.</a:t>
             </a:r>
             <a:endParaRPr lang="en-US" sz="2200" dirty="0"/>
           </a:p>
@@ -4764,7 +4734,7 @@
       </p:sp>
       <p:pic>
         <p:nvPicPr>
-          <p:cNvPr id="6" name="label-pallet" descr="/home/user/physical-inv-app/docs/training/shots/en/label-pallet.png">    </p:cNvPr>
+          <p:cNvPr id="6" name="label-rack" descr="/home/user/physical-inv-app/docs/training/shots/en/label-rack.png">    </p:cNvPr>
           <p:cNvPicPr>
             <a:picLocks noChangeAspect="1"/>
           </p:cNvPicPr>
@@ -4779,76 +4749,13 @@
         <p:spPr>
           <a:xfrm>
             <a:off x="548640" y="4526280"/>
-            <a:ext cx="2834640" cy="1188720"/>
+            <a:ext cx="2834640" cy="1243584"/>
           </a:xfrm>
           <a:prstGeom prst="rect">
             <a:avLst/>
           </a:prstGeom>
         </p:spPr>
       </p:pic>
-      <p:sp>
-        <p:nvSpPr>
-          <p:cNvPr id="7" name="tip box"/>
-          <p:cNvSpPr/>
-          <p:nvPr/>
-        </p:nvSpPr>
-        <p:spPr>
-          <a:xfrm>
-            <a:off x="548640" y="5715000"/>
-            <a:ext cx="6583680" cy="502920"/>
-          </a:xfrm>
-          <a:prstGeom prst="roundRect">
-            <a:avLst>
-              <a:gd name="adj" fmla="val 21818"/>
-            </a:avLst>
-          </a:prstGeom>
-          <a:solidFill>
-            <a:srgbClr val="18293F"/>
-          </a:solidFill>
-          <a:ln w="12700">
-            <a:solidFill>
-              <a:srgbClr val="FFC20E"/>
-            </a:solidFill>
-            <a:prstDash val="solid"/>
-          </a:ln>
-        </p:spPr>
-      </p:sp>
-      <p:sp>
-        <p:nvSpPr>
-          <p:cNvPr id="8" name="tip"/>
-          <p:cNvSpPr txBox="1"/>
-          <p:nvPr/>
-        </p:nvSpPr>
-        <p:spPr>
-          <a:xfrm>
-            <a:off x="713232" y="5715000"/>
-            <a:ext cx="6309360" cy="502920"/>
-          </a:xfrm>
-          <a:prstGeom prst="rect">
-            <a:avLst/>
-          </a:prstGeom>
-          <a:noFill/>
-          <a:ln/>
-        </p:spPr>
-        <p:txBody>
-          <a:bodyPr wrap="square" lIns="0" tIns="0" rIns="0" bIns="0" rtlCol="0" anchor="ctr"/>
-          <a:lstStyle/>
-          <a:p>
-            <a:pPr indent="0" marL="0">
-              <a:buNone/>
-            </a:pPr>
-            <a:r>
-              <a:rPr lang="en-US" sz="1600" b="1" dirty="0">
-                <a:solidFill>
-                  <a:schemeClr val="accent1"/>
-                </a:solidFill>
-              </a:rPr>
-              <a:t>A blind count: you count what is in front of you</a:t>
-            </a:r>
-            <a:endParaRPr lang="en-US" sz="1600" dirty="0"/>
-          </a:p>
-        </p:txBody>
-      </p:sp>
       <p:sp>
         <p:nvSpPr>
           <p:cNvPr id="25" name="Slide Number Placeholder 0"/>
@@ -4989,7 +4896,7 @@
                   <a:schemeClr val="bg1"/>
                 </a:solidFill>
               </a:rPr>
-              <a:t>2 · Count, then type the quantity</a:t>
+              <a:t>2 · Scan the pallet label</a:t>
             </a:r>
             <a:endParaRPr lang="en-US" sz="3200" dirty="0"/>
           </a:p>
@@ -4997,7 +4904,7 @@
       </p:sp>
       <p:pic>
         <p:nvPicPr>
-          <p:cNvPr id="4" name="screen quantity" descr="/home/user/physical-inv-app/docs/training/shots/en/06-quantity.png">    </p:cNvPr>
+          <p:cNvPr id="4" name="screen pallet-scanned" descr="/home/user/physical-inv-app/docs/training/shots/en/06-pallet-scanned.png">    </p:cNvPr>
           <p:cNvPicPr>
             <a:picLocks noChangeAspect="1"/>
           </p:cNvPicPr>
@@ -5028,7 +4935,7 @@
         <p:spPr>
           <a:xfrm>
             <a:off x="548640" y="1691640"/>
-            <a:ext cx="7627289" cy="4206240"/>
+            <a:ext cx="7627289" cy="2651760"/>
           </a:xfrm>
           <a:prstGeom prst="rect">
             <a:avLst/>
@@ -5053,8 +4960,11 @@
                   <a:schemeClr val="bg2"/>
                 </a:solidFill>
               </a:rPr>
-              <a:t>Count the cases that are </a:t>
-            </a:r>
+              <a:t>Now the barcode on the pallet label. Wait for the beep.</a:t>
+            </a:r>
+            <a:endParaRPr lang="en-US" sz="2200" dirty="0"/>
+          </a:p>
+          <a:p>
             <a:pPr algn="l" marL="228600" indent="-228600">
               <a:spcAft>
                 <a:spcPts val="1000"/>
@@ -5063,12 +4973,12 @@
               <a:buChar char="•"/>
             </a:pPr>
             <a:r>
-              <a:rPr lang="en-US" sz="2200" b="1" dirty="0">
-                <a:solidFill>
-                  <a:schemeClr val="bg2"/>
-                </a:solidFill>
-              </a:rPr>
-              <a:t>really there</a:t>
+              <a:rPr lang="en-US" sz="2200" dirty="0">
+                <a:solidFill>
+                  <a:schemeClr val="bg2"/>
+                </a:solidFill>
+              </a:rPr>
+              <a:t>The scanner shows the pallet number. It does </a:t>
             </a:r>
             <a:pPr algn="l" marL="228600" indent="-228600">
               <a:spcAft>
@@ -5078,16 +4988,13 @@
               <a:buChar char="•"/>
             </a:pPr>
             <a:r>
-              <a:rPr lang="en-US" sz="2200" dirty="0">
-                <a:solidFill>
-                  <a:schemeClr val="bg2"/>
-                </a:solidFill>
-              </a:rPr>
-              <a:t>.</a:t>
-            </a:r>
-            <a:endParaRPr lang="en-US" sz="2200" dirty="0"/>
-          </a:p>
-          <a:p>
+              <a:rPr lang="en-US" sz="2200" b="1" dirty="0">
+                <a:solidFill>
+                  <a:schemeClr val="bg2"/>
+                </a:solidFill>
+              </a:rPr>
+              <a:t>not</a:t>
+            </a:r>
             <a:pPr algn="l" marL="228600" indent="-228600">
               <a:spcAft>
                 <a:spcPts val="1000"/>
@@ -5101,42 +5008,96 @@
                   <a:schemeClr val="bg2"/>
                 </a:solidFill>
               </a:rPr>
-              <a:t>Type the number on the number keys, then press Enter.</a:t>
+              <a:t> tell you how many should be there.</a:t>
             </a:r>
             <a:endParaRPr lang="en-US" sz="2200" dirty="0"/>
           </a:p>
-          <a:p>
-            <a:pPr algn="l" marL="228600" indent="-228600">
-              <a:spcAft>
-                <a:spcPts val="1000"/>
-              </a:spcAft>
-              <a:buSzPct val="100000"/>
-              <a:buChar char="•"/>
-            </a:pPr>
-            <a:r>
-              <a:rPr lang="en-US" sz="2200" b="1" dirty="0">
-                <a:solidFill>
-                  <a:schemeClr val="bg2"/>
-                </a:solidFill>
-              </a:rPr>
-              <a:t>Never</a:t>
-            </a:r>
-            <a:pPr algn="l" marL="228600" indent="-228600">
-              <a:spcAft>
-                <a:spcPts val="1000"/>
-              </a:spcAft>
-              <a:buSzPct val="100000"/>
-              <a:buChar char="•"/>
-            </a:pPr>
-            <a:r>
-              <a:rPr lang="en-US" sz="2200" dirty="0">
-                <a:solidFill>
-                  <a:schemeClr val="bg2"/>
-                </a:solidFill>
-              </a:rPr>
-              <a:t> type what you think it should be. A big number may need typing twice.</a:t>
-            </a:r>
-            <a:endParaRPr lang="en-US" sz="2200" dirty="0"/>
+        </p:txBody>
+      </p:sp>
+      <p:pic>
+        <p:nvPicPr>
+          <p:cNvPr id="6" name="label-pallet" descr="/home/user/physical-inv-app/docs/training/shots/en/label-pallet.png">    </p:cNvPr>
+          <p:cNvPicPr>
+            <a:picLocks noChangeAspect="1"/>
+          </p:cNvPicPr>
+          <p:nvPr/>
+        </p:nvPicPr>
+        <p:blipFill>
+          <a:blip r:embed="rId2"/>
+          <a:stretch>
+            <a:fillRect/>
+          </a:stretch>
+        </p:blipFill>
+        <p:spPr>
+          <a:xfrm>
+            <a:off x="548640" y="4526280"/>
+            <a:ext cx="2834640" cy="1188720"/>
+          </a:xfrm>
+          <a:prstGeom prst="rect">
+            <a:avLst/>
+          </a:prstGeom>
+        </p:spPr>
+      </p:pic>
+      <p:sp>
+        <p:nvSpPr>
+          <p:cNvPr id="7" name="tip box"/>
+          <p:cNvSpPr/>
+          <p:nvPr/>
+        </p:nvSpPr>
+        <p:spPr>
+          <a:xfrm>
+            <a:off x="548640" y="5715000"/>
+            <a:ext cx="6583680" cy="502920"/>
+          </a:xfrm>
+          <a:prstGeom prst="roundRect">
+            <a:avLst>
+              <a:gd name="adj" fmla="val 21818"/>
+            </a:avLst>
+          </a:prstGeom>
+          <a:solidFill>
+            <a:srgbClr val="18293F"/>
+          </a:solidFill>
+          <a:ln w="12700">
+            <a:solidFill>
+              <a:srgbClr val="FFC20E"/>
+            </a:solidFill>
+            <a:prstDash val="solid"/>
+          </a:ln>
+        </p:spPr>
+      </p:sp>
+      <p:sp>
+        <p:nvSpPr>
+          <p:cNvPr id="8" name="tip"/>
+          <p:cNvSpPr txBox="1"/>
+          <p:nvPr/>
+        </p:nvSpPr>
+        <p:spPr>
+          <a:xfrm>
+            <a:off x="713232" y="5715000"/>
+            <a:ext cx="6309360" cy="502920"/>
+          </a:xfrm>
+          <a:prstGeom prst="rect">
+            <a:avLst/>
+          </a:prstGeom>
+          <a:noFill/>
+          <a:ln/>
+        </p:spPr>
+        <p:txBody>
+          <a:bodyPr wrap="square" lIns="0" tIns="0" rIns="0" bIns="0" rtlCol="0" anchor="ctr"/>
+          <a:lstStyle/>
+          <a:p>
+            <a:pPr indent="0" marL="0">
+              <a:buNone/>
+            </a:pPr>
+            <a:r>
+              <a:rPr lang="en-US" sz="1600" b="1" dirty="0">
+                <a:solidFill>
+                  <a:schemeClr val="accent1"/>
+                </a:solidFill>
+              </a:rPr>
+              <a:t>A blind count: you count what is in front of you</a:t>
+            </a:r>
+            <a:endParaRPr lang="en-US" sz="1600" dirty="0"/>
           </a:p>
         </p:txBody>
       </p:sp>
@@ -5280,7 +5241,7 @@
                   <a:schemeClr val="bg1"/>
                 </a:solidFill>
               </a:rPr>
-              <a:t>3 · Scan the rack label</a:t>
+              <a:t>3 · Count, then type the quantity</a:t>
             </a:r>
             <a:endParaRPr lang="en-US" sz="3200" dirty="0"/>
           </a:p>
@@ -5288,7 +5249,7 @@
       </p:sp>
       <p:pic>
         <p:nvPicPr>
-          <p:cNvPr id="4" name="screen bin-asked" descr="/home/user/physical-inv-app/docs/training/shots/en/07-bin-asked.png">    </p:cNvPr>
+          <p:cNvPr id="4" name="screen quantity" descr="/home/user/physical-inv-app/docs/training/shots/en/07-quantity.png">    </p:cNvPr>
           <p:cNvPicPr>
             <a:picLocks noChangeAspect="1"/>
           </p:cNvPicPr>
@@ -5319,7 +5280,7 @@
         <p:spPr>
           <a:xfrm>
             <a:off x="548640" y="1691640"/>
-            <a:ext cx="7627289" cy="2651760"/>
+            <a:ext cx="7627289" cy="4206240"/>
           </a:xfrm>
           <a:prstGeom prst="rect">
             <a:avLst/>
@@ -5344,11 +5305,8 @@
                   <a:schemeClr val="bg2"/>
                 </a:solidFill>
               </a:rPr>
-              <a:t>Scan the yellow rack label of the spot the pallet is sitting in.</a:t>
-            </a:r>
-            <a:endParaRPr lang="en-US" sz="2200" dirty="0"/>
-          </a:p>
-          <a:p>
+              <a:t>Count the cases that are </a:t>
+            </a:r>
             <a:pPr algn="l" marL="228600" indent="-228600">
               <a:spcAft>
                 <a:spcPts val="1000"/>
@@ -5357,16 +5315,13 @@
               <a:buChar char="•"/>
             </a:pPr>
             <a:r>
-              <a:rPr lang="en-US" sz="2200" dirty="0">
-                <a:solidFill>
-                  <a:schemeClr val="bg2"/>
-                </a:solidFill>
-              </a:rPr>
-              <a:t>That tells the system where the pallet is.</a:t>
-            </a:r>
-            <a:endParaRPr lang="en-US" sz="2200" dirty="0"/>
-          </a:p>
-          <a:p>
+              <a:rPr lang="en-US" sz="2200" b="1" dirty="0">
+                <a:solidFill>
+                  <a:schemeClr val="bg2"/>
+                </a:solidFill>
+              </a:rPr>
+              <a:t>really there</a:t>
+            </a:r>
             <a:pPr algn="l" marL="228600" indent="-228600">
               <a:spcAft>
                 <a:spcPts val="1000"/>
@@ -5380,36 +5335,63 @@
                   <a:schemeClr val="bg2"/>
                 </a:solidFill>
               </a:rPr>
-              <a:t>The scanner checks it is in your aisle and on your levels.</a:t>
+              <a:t>.</a:t>
             </a:r>
             <a:endParaRPr lang="en-US" sz="2200" dirty="0"/>
           </a:p>
-        </p:txBody>
-      </p:sp>
-      <p:pic>
-        <p:nvPicPr>
-          <p:cNvPr id="6" name="label-rack" descr="/home/user/physical-inv-app/docs/training/shots/en/label-rack.png">    </p:cNvPr>
-          <p:cNvPicPr>
-            <a:picLocks noChangeAspect="1"/>
-          </p:cNvPicPr>
-          <p:nvPr/>
-        </p:nvPicPr>
-        <p:blipFill>
-          <a:blip r:embed="rId2"/>
-          <a:stretch>
-            <a:fillRect/>
-          </a:stretch>
-        </p:blipFill>
-        <p:spPr>
-          <a:xfrm>
-            <a:off x="548640" y="4526280"/>
-            <a:ext cx="2834640" cy="1243584"/>
-          </a:xfrm>
-          <a:prstGeom prst="rect">
-            <a:avLst/>
-          </a:prstGeom>
-        </p:spPr>
-      </p:pic>
+          <a:p>
+            <a:pPr algn="l" marL="228600" indent="-228600">
+              <a:spcAft>
+                <a:spcPts val="1000"/>
+              </a:spcAft>
+              <a:buSzPct val="100000"/>
+              <a:buChar char="•"/>
+            </a:pPr>
+            <a:r>
+              <a:rPr lang="en-US" sz="2200" dirty="0">
+                <a:solidFill>
+                  <a:schemeClr val="bg2"/>
+                </a:solidFill>
+              </a:rPr>
+              <a:t>Type the number on the number keys, then press Enter.</a:t>
+            </a:r>
+            <a:endParaRPr lang="en-US" sz="2200" dirty="0"/>
+          </a:p>
+          <a:p>
+            <a:pPr algn="l" marL="228600" indent="-228600">
+              <a:spcAft>
+                <a:spcPts val="1000"/>
+              </a:spcAft>
+              <a:buSzPct val="100000"/>
+              <a:buChar char="•"/>
+            </a:pPr>
+            <a:r>
+              <a:rPr lang="en-US" sz="2200" b="1" dirty="0">
+                <a:solidFill>
+                  <a:schemeClr val="bg2"/>
+                </a:solidFill>
+              </a:rPr>
+              <a:t>Never</a:t>
+            </a:r>
+            <a:pPr algn="l" marL="228600" indent="-228600">
+              <a:spcAft>
+                <a:spcPts val="1000"/>
+              </a:spcAft>
+              <a:buSzPct val="100000"/>
+              <a:buChar char="•"/>
+            </a:pPr>
+            <a:r>
+              <a:rPr lang="en-US" sz="2200" dirty="0">
+                <a:solidFill>
+                  <a:schemeClr val="bg2"/>
+                </a:solidFill>
+              </a:rPr>
+              <a:t> type what you think it should be. A big number may need typing twice.</a:t>
+            </a:r>
+            <a:endParaRPr lang="en-US" sz="2200" dirty="0"/>
+          </a:p>
+        </p:txBody>
+      </p:sp>
       <p:sp>
         <p:nvSpPr>
           <p:cNvPr id="25" name="Slide Number Placeholder 0"/>
@@ -5953,7 +5935,7 @@
                   <a:schemeClr val="bg2"/>
                 </a:solidFill>
               </a:rPr>
-              <a:t>If you scan the rack label when it asks for the pallet, the scanner says so and records nothing.</a:t>
+              <a:t>If you scan the pallet label when it asks for the rack, the scanner says so and records nothing.</a:t>
             </a:r>
             <a:endParaRPr lang="en-US" sz="2200" dirty="0"/>
           </a:p>
@@ -6689,7 +6671,7 @@
                   <a:schemeClr val="bg2"/>
                 </a:solidFill>
               </a:rPr>
-              <a:t>Nothing in the spot? That counts too.</a:t>
+              <a:t>Nothing in the spot? That counts too. Scan the rack label as usual.</a:t>
             </a:r>
             <a:endParaRPr lang="en-US" sz="2200" dirty="0"/>
           </a:p>
@@ -6707,7 +6689,7 @@
                   <a:schemeClr val="bg2"/>
                 </a:solidFill>
               </a:rPr>
-              <a:t>Tap </a:t>
+              <a:t>Then tap </a:t>
             </a:r>
             <a:pPr algn="l" marL="228600" indent="-228600">
               <a:spcAft>
@@ -6722,7 +6704,7 @@
                   <a:schemeClr val="bg2"/>
                 </a:solidFill>
               </a:rPr>
-              <a:t>Bin is EMPTY — scan the bin</a:t>
+              <a:t>Bin is EMPTY</a:t>
             </a:r>
             <a:pPr algn="l" marL="228600" indent="-228600">
               <a:spcAft>
@@ -6737,7 +6719,37 @@
                   <a:schemeClr val="bg2"/>
                 </a:solidFill>
               </a:rPr>
-              <a:t>, then scan the rack label.</a:t>
+              <a:t>, and </a:t>
+            </a:r>
+            <a:pPr algn="l" marL="228600" indent="-228600">
+              <a:spcAft>
+                <a:spcPts val="1000"/>
+              </a:spcAft>
+              <a:buSzPct val="100000"/>
+              <a:buChar char="•"/>
+            </a:pPr>
+            <a:r>
+              <a:rPr lang="en-US" sz="2200" b="1" dirty="0">
+                <a:solidFill>
+                  <a:schemeClr val="bg2"/>
+                </a:solidFill>
+              </a:rPr>
+              <a:t>Yes — it is empty</a:t>
+            </a:r>
+            <a:pPr algn="l" marL="228600" indent="-228600">
+              <a:spcAft>
+                <a:spcPts val="1000"/>
+              </a:spcAft>
+              <a:buSzPct val="100000"/>
+              <a:buChar char="•"/>
+            </a:pPr>
+            <a:r>
+              <a:rPr lang="en-US" sz="2200" dirty="0">
+                <a:solidFill>
+                  <a:schemeClr val="bg2"/>
+                </a:solidFill>
+              </a:rPr>
+              <a:t>.</a:t>
             </a:r>
             <a:endParaRPr lang="en-US" sz="2200" dirty="0"/>
           </a:p>
@@ -7175,7 +7187,7 @@
                   <a:schemeClr val="bg2"/>
                 </a:solidFill>
               </a:rPr>
-              <a:t>Tap </a:t>
+              <a:t>Scan the rack as usual · tap </a:t>
             </a:r>
             <a:pPr algn="l" indent="0" marL="0">
               <a:spcAft>
@@ -7203,7 +7215,7 @@
                   <a:schemeClr val="bg2"/>
                 </a:solidFill>
               </a:rPr>
-              <a:t> · scan the rack once · label 1 and its cases · label 2 and its cases · </a:t>
+              <a:t> · label 1 and its cases · label 2 and its cases · </a:t>
             </a:r>
             <a:pPr algn="l" indent="0" marL="0">
               <a:spcAft>
@@ -10721,7 +10733,7 @@
                   <a:schemeClr val="accent1"/>
                 </a:solidFill>
               </a:rPr>
-              <a:t>Pallet · Quantity · Rack — over and over</a:t>
+              <a:t>Rack · Pallet · Quantity — over and over</a:t>
             </a:r>
             <a:endParaRPr lang="en-US" sz="1600" dirty="0"/>
           </a:p>
@@ -11051,7 +11063,7 @@
                   <a:schemeClr val="bg2"/>
                 </a:solidFill>
               </a:rPr>
-              <a:t>Go to the spot and count everything in it — pallet, quantity, rack. Then tap </a:t>
+              <a:t>Go to the spot and count everything in it — rack, pallet, quantity. Then tap </a:t>
             </a:r>
             <a:pPr algn="l" marL="228600" indent="-228600">
               <a:spcAft>
@@ -12083,7 +12095,7 @@
                           <a:ea typeface="+mn-lt" pitchFamily="34" charset="-122"/>
                           <a:cs typeface="+mn-lt" pitchFamily="34" charset="-120"/>
                         </a:rPr>
-                        <a:t>Nothing in the spot. Then scan the rack</a:t>
+                        <a:t>Nothing in the spot: after the rack, tap it, then Yes</a:t>
                       </a:r>
                       <a:endParaRPr lang="en-US" sz="1400" dirty="0">
                         <a:latin typeface="+mn-lt" charset="0"/>
@@ -12359,7 +12371,7 @@
                           <a:ea typeface="+mn-lt" pitchFamily="34" charset="-122"/>
                           <a:cs typeface="+mn-lt" pitchFamily="34" charset="-120"/>
                         </a:rPr>
-                        <a:t>Rack once, then each label with its cases, then Done</a:t>
+                        <a:t>After the rack: each label with its cases, then Done</a:t>
                       </a:r>
                       <a:endParaRPr lang="en-US" sz="1400" dirty="0">
                         <a:latin typeface="+mn-lt" charset="0"/>
@@ -13797,7 +13809,7 @@
                   <a:schemeClr val="bg1"/>
                 </a:solidFill>
               </a:rPr>
-              <a:t>Pallet · Quantity · Rack</a:t>
+              <a:t>Rack · Pallet · Quantity</a:t>
             </a:r>
             <a:endParaRPr lang="en-US" sz="5400" dirty="0"/>
           </a:p>
@@ -15171,7 +15183,7 @@
                   <a:schemeClr val="bg2"/>
                 </a:solidFill>
               </a:rPr>
-              <a:t>Three steps, over and over: the pallet, the quantity, the rack.</a:t>
+              <a:t>Three steps, over and over: the rack, the pallet, the quantity.</a:t>
             </a:r>
             <a:endParaRPr lang="en-US" sz="2400" dirty="0"/>
           </a:p>

</xml_diff>